<commit_message>
feat: 命令行客户端 ls search / ls import（A2）
新增令牌搜索接口、CLI 子命令与 ls 入口，复用预览/查重/入库流程；
补充单元与集成测试，并同步 README、报告、需求、路线图与 PPT。
</commit_message>
<xml_diff>
--- a/docs/汇报.pptx
+++ b/docs/汇报.pptx
@@ -11238,7 +11238,7 @@
                 </a:solidFill>
                 <a:latin typeface="Microsoft YaHei"/>
               </a:rPr>
-              <a:t>238 项测试与 39 项端到端验收全部通过</a:t>
+              <a:t>247 项测试与 39 项端到端验收全部通过</a:t>
             </a:r>
           </a:p>
         </p:txBody>
@@ -11445,7 +11445,7 @@
                 </a:solidFill>
                 <a:latin typeface="Microsoft YaHei"/>
               </a:rPr>
-              <a:t>238</a:t>
+              <a:t>247</a:t>
             </a:r>
           </a:p>
         </p:txBody>
@@ -11834,7 +11834,7 @@
                 </a:solidFill>
                 <a:latin typeface="Consolas"/>
               </a:rPr>
-              <a:t># 137 unit + 101 integration</a:t>
+              <a:t># 143 unit + 104 integration</a:t>
             </a:r>
           </a:p>
           <a:p>
@@ -14311,7 +14311,7 @@
                 </a:solidFill>
                 <a:latin typeface="Microsoft YaHei"/>
               </a:rPr>
-              <a:t>• 238 项测试 + 39 项验收，全部通过</a:t>
+              <a:t>• 247 项测试 + 39 项验收，全部通过</a:t>
             </a:r>
           </a:p>
           <a:p>

</xml_diff>